<commit_message>
Iterationen 1 bis 7, Bericht als Entwurf, Protokolle der H-, Gate- und Review-Tests
Leitfaden nach Lauf 2: Regel ohne Auslöser wird Szenario ohne Wenn, Preis und
Bestand sind beobachtbar, Glossar-Spalte "Am Automaten" verbindet Fachwort und
Methode, aufgehobene Regeln dürfen alte Szenarien ändern, EARS-Regeln bleiben
allgemein. Folie 10 mit Baseline gegen Pipeline aus Lauf 2, Story 1.
Protokolle: Lauf 2 bis Story 4 abgebrochen, H1-H4, vier Gates, Review-Test
mit eingebautem Smell (drei Befunde).

Co-Authored-By: Claude Fable 5.1 <noreply@anthropic.com>
Claude-Session: https://claude.ai/code/session_014k7Vpv7dAogbAAM66KtWMX
</commit_message>
<xml_diff>
--- a/folien/folien.pptx
+++ b/folien/folien.pptx
@@ -3265,7 +3265,7 @@
                   <a:srgbClr val="0B5FA5"/>
                 </a:solidFill>
               </a:rPr>
-              <a:t>Vanilla opencode</a:t>
+              <a:t>Vanilla opencode, zwei Versuche</a:t>
             </a:r>
           </a:p>
           <a:p>
@@ -3280,7 +3280,37 @@
                   <a:srgbClr val="1F2933"/>
                 </a:solidFill>
               </a:rPr>
-              <a:t>•  PLATZHALTER BASELINE</a:t>
+              <a:t>•  Versuch 1, 57 Sekunden: mvn -q verify grün. 16 Zeilen in VendingMachine.java, kein Test, keine Spec.</a:t>
+            </a:r>
+          </a:p>
+          <a:p>
+            <a:pPr>
+              <a:spcAft>
+                <a:spcPts val="600"/>
+              </a:spcAft>
+            </a:pPr>
+            <a:r>
+              <a:rPr sz="1800" b="0">
+                <a:solidFill>
+                  <a:srgbClr val="1F2933"/>
+                </a:solidFill>
+              </a:rPr>
+              <a:t>•  Nebenbei takeCoins und coinReturn gebaut, die keine Story verlangt.</a:t>
+            </a:r>
+          </a:p>
+          <a:p>
+            <a:pPr>
+              <a:spcAft>
+                <a:spcPts val="600"/>
+              </a:spcAft>
+            </a:pPr>
+            <a:r>
+              <a:rPr sz="1800" b="0">
+                <a:solidFill>
+                  <a:srgbClr val="1F2933"/>
+                </a:solidFill>
+              </a:rPr>
+              <a:t>•  Versuch 2, 10 Sekunden: Dateipfad außerhalb des Projekts erfunden, Rechteabfrage abgelehnt, aufgehört.</a:t>
             </a:r>
           </a:p>
         </p:txBody>
@@ -3320,7 +3350,7 @@
                   <a:srgbClr val="0B5FA5"/>
                 </a:solidFill>
               </a:rPr>
-              <a:t>Mit Pipeline</a:t>
+              <a:t>Mit Pipeline, vier Minuten</a:t>
             </a:r>
           </a:p>
           <a:p>
@@ -3335,7 +3365,52 @@
                   <a:srgbClr val="1F2933"/>
                 </a:solidFill>
               </a:rPr>
-              <a:t>•  PLATZHALTER PIPELINE</a:t>
+              <a:t>•  /spec: eine EARS-Regel, keine offenen Fragen.</a:t>
+            </a:r>
+          </a:p>
+          <a:p>
+            <a:pPr>
+              <a:spcAft>
+                <a:spcPts val="600"/>
+              </a:spcAft>
+            </a:pPr>
+            <a:r>
+              <a:rPr sz="1800" b="0">
+                <a:solidFill>
+                  <a:srgbClr val="1F2933"/>
+                </a:solidFill>
+              </a:rPr>
+              <a:t>•  /akzeptanztest: zweites Szenario „Auch Bier fällt gratis“, beide rot.</a:t>
+            </a:r>
+          </a:p>
+          <a:p>
+            <a:pPr>
+              <a:spcAft>
+                <a:spcPts val="600"/>
+              </a:spcAft>
+            </a:pPr>
+            <a:r>
+              <a:rPr sz="1800" b="0">
+                <a:solidFill>
+                  <a:srgbClr val="1F2933"/>
+                </a:solidFill>
+              </a:rPr>
+              <a:t>•  /implementiere: roter Unit-Test zuerst, dann neun Zeilen Code, verify grün.</a:t>
+            </a:r>
+          </a:p>
+          <a:p>
+            <a:pPr>
+              <a:spcAft>
+                <a:spcPts val="600"/>
+              </a:spcAft>
+            </a:pPr>
+            <a:r>
+              <a:rPr sz="1800" b="0">
+                <a:solidFill>
+                  <a:srgbClr val="1F2933"/>
+                </a:solidFill>
+              </a:rPr>
+              <a:t>•  /review: zwei Befunde mit Datei:Zeile, zum Bestand und zum Szenariotitel.</a:t>
             </a:r>
           </a:p>
         </p:txBody>
@@ -3416,7 +3491,7 @@
                   <a:srgbClr val="1F2933"/>
                 </a:solidFill>
               </a:rPr>
-              <a:t>PLATZHALTER FUSS</a:t>
+              <a:t>Gleiches Modell, gleiche Story. Der Unterschied: Regeln, Szenarien, Test und Review, jedes Mal in dieser Reihenfolge.</a:t>
             </a:r>
           </a:p>
         </p:txBody>
@@ -6383,7 +6458,7 @@
                   <a:srgbClr val="1F2933"/>
                 </a:solidFill>
               </a:rPr>
-              <a:t>1. Ein Szenario, ein Verhalten: genau ein Wenn.</a:t>
+              <a:t>1. Ein Szenario, ein Verhalten: genau ein Wenn, keins bei einer Regel ohne Auslöser.</a:t>
             </a:r>
           </a:p>
           <a:p>
@@ -6428,7 +6503,7 @@
                   <a:srgbClr val="1F2933"/>
                 </a:solidFill>
               </a:rPr>
-              <a:t>4. Angenommen ist Zustand, Wenn ist Ereignis, Dann ist von außen sichtbar.</a:t>
+              <a:t>4. Angenommen ist Zustand, Wenn ist Ereignis, Dann ist von außen sichtbar: Dose, Guthaben, Meldung, Preis, Bestand.</a:t>
             </a:r>
           </a:p>
           <a:p>

</xml_diff>

<commit_message>
Iteration 11: veralteter Test wird angepasst, nie Main festgenagelt; Lauf 6 bis Story 2
Co-Authored-By: Claude Fable 5.1 <noreply@anthropic.com>
Claude-Session: https://claude.ai/code/session_014k7Vpv7dAogbAAM66KtWMX
</commit_message>
<xml_diff>
--- a/folien/folien.pptx
+++ b/folien/folien.pptx
@@ -3350,7 +3350,7 @@
                   <a:srgbClr val="0B5FA5"/>
                 </a:solidFill>
               </a:rPr>
-              <a:t>Mit Pipeline, vier Minuten</a:t>
+              <a:t>Mit Pipeline, viereinhalb Minuten</a:t>
             </a:r>
           </a:p>
           <a:p>
@@ -3365,7 +3365,7 @@
                   <a:srgbClr val="1F2933"/>
                 </a:solidFill>
               </a:rPr>
-              <a:t>•  /spec: eine EARS-Regel, keine offenen Fragen.</a:t>
+              <a:t>•  /spec: eine Regel: WHILE eine Dose im Fach ist, WHEN der Kunde ein Fach wählt, SHALL … Keine offenen Fragen.</a:t>
             </a:r>
           </a:p>
           <a:p>
@@ -3380,7 +3380,7 @@
                   <a:srgbClr val="1F2933"/>
                 </a:solidFill>
               </a:rPr>
-              <a:t>•  /akzeptanztest: zweites Szenario „Auch Bier fällt gratis“, beide rot.</a:t>
+              <a:t>•  /akzeptanztest: zweites Szenario „Guthaben bleibt beim freien Getränk gleich“, beide rot.</a:t>
             </a:r>
           </a:p>
           <a:p>
@@ -3395,7 +3395,7 @@
                   <a:srgbClr val="1F2933"/>
                 </a:solidFill>
               </a:rPr>
-              <a:t>•  /implementiere: roter Unit-Test zuerst, dann neun Zeilen Code, verify grün.</a:t>
+              <a:t>•  /implementiere: Unit-Test zuerst rot, dann zehn Zeilen Code, verify grün.</a:t>
             </a:r>
           </a:p>
           <a:p>
@@ -3410,7 +3410,7 @@
                   <a:srgbClr val="1F2933"/>
                 </a:solidFill>
               </a:rPr>
-              <a:t>•  /review: zwei Befunde mit Datei:Zeile, zum Bestand und zum Szenariotitel.</a:t>
+              <a:t>•  /review: ein Befund mit Datei:Zeile: der Bestand wird beim Ausgeben nicht verringert.</a:t>
             </a:r>
           </a:p>
         </p:txBody>

</xml_diff>

<commit_message>
Iteration 14: keine Story-Lösungen mehr in Skills, Command und Folie 8
Auf Sebastians Wunsch: die Beispiele „Kein Bier vor 4“, Preise, „Zu wenig
Geld“ und die Hinweise auf das freie Getränk aus den Skills, dem Command
/akzeptanztest und Folie 8 entfernt. Neue Beispiele ohne Story: ein leeres
Fach meldet „Ausverkauft“, jedes Fach startet mit fünf Dosen. Nicht mehr
mit Läufen verifiziert, steht so in ITERATIONEN.md und im Bericht.

Co-Authored-By: Claude Fable 5.1 <noreply@anthropic.com>
Claude-Session: https://claude.ai/code/session_014k7Vpv7dAogbAAM66KtWMX
</commit_message>
<xml_diff>
--- a/folien/folien.pptx
+++ b/folien/folien.pptx
@@ -6236,7 +6236,7 @@
                 </a:solidFill>
                 <a:latin typeface="Menlo"/>
               </a:rPr>
-              <a:t>EARS      WHILE es vor 16:00 Uhr ist, WHEN der Kunde Bier wählt,</a:t>
+              <a:t>EARS      WHILE das Fach leer ist, WHEN der Kunde es wählt,</a:t>
             </a:r>
           </a:p>
           <a:p>
@@ -6252,7 +6252,7 @@
                 </a:solidFill>
                 <a:latin typeface="Menlo"/>
               </a:rPr>
-              <a:t>          SHALL der Automat keine Dose ausgeben und "Kein Bier vor 4" melden.</a:t>
+              <a:t>          SHALL der Automat keine Dose ausgeben und "Ausverkauft" melden.</a:t>
             </a:r>
           </a:p>
           <a:p>
@@ -6284,7 +6284,7 @@
                 </a:solidFill>
                 <a:latin typeface="Menlo"/>
               </a:rPr>
-              <a:t>Gherkin   Szenario: Vor 16 Uhr fällt kein Bier</a:t>
+              <a:t>Gherkin   Szenario: Aus einem leeren Fach fällt nichts</a:t>
             </a:r>
           </a:p>
           <a:p>
@@ -6300,7 +6300,7 @@
                 </a:solidFill>
                 <a:latin typeface="Menlo"/>
               </a:rPr>
-              <a:t>            Angenommen es ist 15:59 Uhr</a:t>
+              <a:t>            Angenommen das Fach Cola ist leer</a:t>
             </a:r>
           </a:p>
           <a:p>
@@ -6316,7 +6316,7 @@
                 </a:solidFill>
                 <a:latin typeface="Menlo"/>
               </a:rPr>
-              <a:t>            Und ich habe 2 € eingeworfen</a:t>
+              <a:t>            Wenn ich Cola wähle</a:t>
             </a:r>
           </a:p>
           <a:p>
@@ -6332,7 +6332,7 @@
                 </a:solidFill>
                 <a:latin typeface="Menlo"/>
               </a:rPr>
-              <a:t>            Wenn ich Bier wähle</a:t>
+              <a:t>            Dann ist das Ausgabefach leer</a:t>
             </a:r>
           </a:p>
           <a:p>
@@ -6348,23 +6348,7 @@
                 </a:solidFill>
                 <a:latin typeface="Menlo"/>
               </a:rPr>
-              <a:t>            Dann ist das Ausgabefach leer</a:t>
-            </a:r>
-          </a:p>
-          <a:p>
-            <a:pPr>
-              <a:spcAft>
-                <a:spcPts val="600"/>
-              </a:spcAft>
-            </a:pPr>
-            <a:r>
-              <a:rPr sz="1600" b="0">
-                <a:solidFill>
-                  <a:srgbClr val="1F2933"/>
-                </a:solidFill>
-                <a:latin typeface="Menlo"/>
-              </a:rPr>
-              <a:t>            Und der Automat meldet "Kein Bier vor 4"</a:t>
+              <a:t>            Und der Automat meldet "Ausverkauft"</a:t>
             </a:r>
           </a:p>
         </p:txBody>

</xml_diff>